<commit_message>
Slides v6: task 4 tied to the 8-pile model and its 10 % range; careful wording on T4-02 and P14
</commit_message>
<xml_diff>
--- a/ppt_slide_topics/Sunflower_Weight_Estimation_v6_8min.pptx
+++ b/ppt_slide_topics/Sunflower_Weight_Estimation_v6_8min.pptx
@@ -3229,7 +3229,7 @@
           <a:lstStyle/>
           <a:p>
             <a:r>
-              <a:t>Hadi, 15 seconds. We skip the assignment intro: all groups have the same one. Our answer in one line: one photo gives the weight within plus or minus 8.7 percent, and it held when Jia repeated it on 9 new piles.</a:t>
+              <a:t>Hadi, 15 seconds. We skip the assignment intro: all groups have the same one. Our answer in one line: one photo gives the weight within plus or minus 8.7 percent, and when Jia repeated the procedure on 9 new piles, all 9 fell inside the range.</a:t>
             </a:r>
           </a:p>
         </p:txBody>
@@ -3473,7 +3473,7 @@
           <a:lstStyle/>
           <a:p>
             <a:r>
-              <a:t>Hadi, about 2 minutes. The range for one photo is plus or minus 8.7 percent: 19 of 20 true weights should fall inside. Where does the error come from? The photo adds only 0.9 percent; the 1 gram kitchen scale 1.7; the rest, 3.5 percent, is the seeds themselves and what we could not measure. Jia's 9 new piles: all inside, average error minus 1.4 percent. Business case: after 10 piles, one more pile buys less than 0.2 points, so 10 piles is where we would stop.</a:t>
+              <a:t>Hadi, about 2 minutes. The range for one photo is plus or minus 8.7 percent: 19 of 20 true weights should fall inside. Where does the error come from? The photo adds only 0.9 percent; the 1 gram kitchen scale 1.7; the rest, 3.5 percent, is the seeds themselves and what we could not measure. Jia's 9 new piles, tested with Hadi's 8-pile model and its plus or minus 10 percent range: all inside, average error minus 1.4 percent. Then we pooled all 17 piles. Business case: after 10 piles, one more pile buys less than 0.2 points, so 10 piles is where we would stop.</a:t>
             </a:r>
           </a:p>
         </p:txBody>
@@ -13470,7 +13470,7 @@
           <a:p>
             <a:pPr/>
             <a:r>
-              <a:t>One photo gives the weight within ±8.7 % (95 % range). It held for a second person: 9 of 9 test piles inside.</a:t>
+              <a:t>One photo gives the weight within ±8.7 % (95 % range). Tested by a second person: 9 of 9 new piles inside the range.</a:t>
             </a:r>
           </a:p>
         </p:txBody>
@@ -14290,7 +14290,7 @@
             </a:pPr>
             <a:r>
               <a:rPr sz="1600"/>
-              <a:t>・Hadi's 8 piles to build the model; Jia's 9 new piles to test it (task 4).</a:t>
+              <a:t>・Hadi's 8 piles built the first model; Jia's 9 new piles tested it (task 4); then all 17 were pooled.</a:t>
             </a:r>
             <a:endParaRPr sz="1600"/>
           </a:p>
@@ -15757,7 +15757,7 @@
               </a:defRPr>
             </a:pPr>
             <a:r>
-              <a:t>Jia's 9 new piles: 9 of 9 inside, average error -1.4 %.</a:t>
+              <a:t>Jia's 9 new piles: 9 of 9 inside the ±10 % range of Hadi's 8-pile model, average error -1.4 %. Then all 17 piles were pooled: ±8.7 %.</a:t>
             </a:r>
             <a:endParaRPr sz="1600"/>
           </a:p>
@@ -17913,7 +17913,7 @@
           <a:p>
             <a:pPr/>
             <a:r>
-              <a:t>Weighed in a container</a:t>
+              <a:t>Weighed in a container?</a:t>
             </a:r>
           </a:p>
         </p:txBody>
@@ -17961,7 +17961,7 @@
           <a:p>
             <a:pPr/>
             <a:r>
-              <a:t>T4-02: 14 g before, 12 g after. Now: weigh straight on the scale, before and after.</a:t>
+              <a:t>T4-02: 14 g before, 12 g after, probably the container. Now: weigh straight on the scale.</a:t>
             </a:r>
           </a:p>
         </p:txBody>
@@ -18442,7 +18442,7 @@
           <a:p>
             <a:pPr/>
             <a:r>
-              <a:t>Above 651 seeds (P14: +15 %); coin or bank card as ruler; seeds without hulls.</a:t>
+              <a:t>Above 651 seeds (untested); coin or bank card as ruler; seeds without hulls.</a:t>
             </a:r>
           </a:p>
         </p:txBody>

</xml_diff>

<commit_message>
Slides v6: full names and student numbers, app screenshot slide
</commit_message>
<xml_diff>
--- a/ppt_slide_topics/Sunflower_Weight_Estimation_v6_8min.pptx
+++ b/ppt_slide_topics/Sunflower_Weight_Estimation_v6_8min.pptx
@@ -13,6 +13,7 @@
     <p:sldId id="274" r:id="rId26"/>
     <p:sldId id="275" r:id="rId27"/>
     <p:sldId id="276" r:id="rId28"/>
+    <p:sldId id="279" r:id="rId31"/>
     <p:sldId id="277" r:id="rId29"/>
     <p:sldId id="278" r:id="rId30"/>
     <p:sldId id="256" r:id="rId8"/>
@@ -3648,6 +3649,64 @@
           <a:p>
             <a:r>
               <a:t>Backup slides, not presented.</a:t>
+            </a:r>
+          </a:p>
+        </p:txBody>
+      </p:sp>
+    </p:spTree>
+  </p:cSld>
+  <p:clrMapOvr>
+    <a:masterClrMapping/>
+  </p:clrMapOvr>
+</p:notes>
+</file>
+
+<file path=ppt/notesSlides/notesSlide24.xml><?xml version="1.0" encoding="utf-8"?>
+<p:notes xmlns:a="http://schemas.openxmlformats.org/drawingml/2006/main" xmlns:p="http://schemas.openxmlformats.org/presentationml/2006/main" xmlns:r="http://schemas.openxmlformats.org/officeDocument/2006/relationships">
+  <p:cSld>
+    <p:spTree>
+      <p:nvGrpSpPr>
+        <p:cNvPr id="1" name=""/>
+        <p:cNvGrpSpPr/>
+        <p:nvPr/>
+      </p:nvGrpSpPr>
+      <p:grpSpPr>
+        <a:xfrm>
+          <a:off x="0" y="0"/>
+          <a:ext cx="0" cy="0"/>
+          <a:chOff x="0" y="0"/>
+          <a:chExt cx="0" cy="0"/>
+        </a:xfrm>
+      </p:grpSpPr>
+      <p:sp>
+        <p:nvSpPr>
+          <p:cNvPr id="2" name="Slide Image Placeholder 1"/>
+          <p:cNvSpPr>
+            <a:spLocks noGrp="1"/>
+          </p:cNvSpPr>
+          <p:nvPr>
+            <p:ph type="sldImg"/>
+          </p:nvPr>
+        </p:nvSpPr>
+        <p:spPr/>
+      </p:sp>
+      <p:sp>
+        <p:nvSpPr>
+          <p:cNvPr id="3" name="Notes Placeholder 2"/>
+          <p:cNvSpPr>
+            <a:spLocks noGrp="1"/>
+          </p:cNvSpPr>
+          <p:nvPr>
+            <p:ph type="body" idx="1" sz="quarter"/>
+          </p:nvPr>
+        </p:nvSpPr>
+        <p:spPr/>
+        <p:txBody>
+          <a:bodyPr/>
+          <a:lstStyle/>
+          <a:p>
+            <a:r>
+              <a:t>Hadi, about 20 seconds, or skip if time is short. A real run of the app on our 24 photos of 19 October: the light is green for the good photos and orange, with the right sentence, for the 4 photos with touching seeds.</a:t>
             </a:r>
           </a:p>
         </p:txBody>
@@ -13514,7 +13573,7 @@
           <a:p>
             <a:pPr/>
             <a:r>
-              <a:t>Hadi Nasooti and Jia  |  KU Leuven  |  26 October 2026</a:t>
+              <a:t>Hadi Nasooti (R0650483) and Chunhui Jia (R1134557)  |  KU Leuven  |  26 October 2026</a:t>
             </a:r>
           </a:p>
         </p:txBody>
@@ -19334,7 +19393,253 @@
           <a:p>
             <a:pPr/>
             <a:r>
-              <a:t>Hadi Nasooti and Jia  |  KU Leuven  |  26 October 2026</a:t>
+              <a:t>Hadi Nasooti (R0650483) and Chunhui Jia (R1134557)  |  KU Leuven  |  26 October 2026</a:t>
+            </a:r>
+          </a:p>
+        </p:txBody>
+      </p:sp>
+    </p:spTree>
+  </p:cSld>
+  <p:clrMapOvr>
+    <a:masterClrMapping/>
+  </p:clrMapOvr>
+</p:sld>
+</file>
+
+<file path=ppt/slides/slide24.xml><?xml version="1.0" encoding="utf-8"?>
+<p:sld xmlns:a="http://schemas.openxmlformats.org/drawingml/2006/main" xmlns:p="http://schemas.openxmlformats.org/presentationml/2006/main" xmlns:r="http://schemas.openxmlformats.org/officeDocument/2006/relationships">
+  <p:cSld>
+    <p:spTree>
+      <p:nvGrpSpPr>
+        <p:cNvPr id="1" name=""/>
+        <p:cNvGrpSpPr/>
+        <p:nvPr/>
+      </p:nvGrpSpPr>
+      <p:grpSpPr/>
+      <p:sp>
+        <p:nvSpPr>
+          <p:cNvPr id="128" name="Text 0"/>
+          <p:cNvSpPr txBox="1"/>
+          <p:nvPr/>
+        </p:nvSpPr>
+        <p:spPr>
+          <a:xfrm>
+            <a:off x="548640" y="434340"/>
+            <a:ext cx="9509760" cy="457201"/>
+          </a:xfrm>
+          <a:prstGeom prst="rect">
+            <a:avLst/>
+          </a:prstGeom>
+          <a:ln w="12700">
+            <a:miter lim="400000"/>
+          </a:ln>
+          <a:extLst>
+            <a:ext uri="{C572A759-6A51-4108-AA02-DFA0A04FC94B}">
+              <ma14:wrappingTextBoxFlag xmlns:ma14="http://schemas.microsoft.com/office/mac/drawingml/2011/main" val="1"/>
+            </a:ext>
+          </a:extLst>
+        </p:spPr>
+        <p:txBody>
+          <a:bodyPr lIns="0" tIns="0" rIns="0" bIns="0" anchor="ctr">
+            <a:spAutoFit/>
+          </a:bodyPr>
+          <a:lstStyle>
+            <a:lvl1pPr>
+              <a:defRPr sz="3000">
+                <a:solidFill>
+                  <a:srgbClr val="2D5B3F"/>
+                </a:solidFill>
+                <a:latin typeface="Cambria"/>
+                <a:ea typeface="Cambria"/>
+                <a:cs typeface="Cambria"/>
+                <a:sym typeface="Cambria"/>
+              </a:defRPr>
+            </a:lvl1pPr>
+          </a:lstStyle>
+          <a:p>
+            <a:pPr/>
+            <a:r>
+              <a:t>The app on our own photos</a:t>
+            </a:r>
+          </a:p>
+        </p:txBody>
+      </p:sp>
+      <p:sp>
+        <p:nvSpPr>
+          <p:cNvPr id="129" name="Text 1"/>
+          <p:cNvSpPr txBox="1"/>
+          <p:nvPr/>
+        </p:nvSpPr>
+        <p:spPr>
+          <a:xfrm>
+            <a:off x="9692640" y="527226"/>
+            <a:ext cx="2011680" cy="134268"/>
+          </a:xfrm>
+          <a:prstGeom prst="rect">
+            <a:avLst/>
+          </a:prstGeom>
+          <a:ln w="12700">
+            <a:miter lim="400000"/>
+          </a:ln>
+          <a:extLst>
+            <a:ext uri="{C572A759-6A51-4108-AA02-DFA0A04FC94B}">
+              <ma14:wrappingTextBoxFlag xmlns:ma14="http://schemas.microsoft.com/office/mac/drawingml/2011/main" val="1"/>
+            </a:ext>
+          </a:extLst>
+        </p:spPr>
+        <p:txBody>
+          <a:bodyPr lIns="0" tIns="0" rIns="0" bIns="0" anchor="ctr">
+            <a:spAutoFit/>
+          </a:bodyPr>
+          <a:lstStyle>
+            <a:lvl1pPr algn="r">
+              <a:defRPr b="1" spc="200" sz="1100">
+                <a:solidFill>
+                  <a:srgbClr val="DC8F14"/>
+                </a:solidFill>
+              </a:defRPr>
+            </a:lvl1pPr>
+          </a:lstStyle>
+          <a:p>
+            <a:pPr/>
+            <a:r>
+              <a:t>APP</a:t>
+            </a:r>
+          </a:p>
+        </p:txBody>
+      </p:sp>
+      <p:sp>
+        <p:nvSpPr>
+          <p:cNvPr id="134" name="Slide Number Placeholder 0"/>
+          <p:cNvSpPr txBox="1"/>
+          <p:nvPr>
+            <p:ph type="sldNum" sz="quarter" idx="4294967295"/>
+          </p:nvPr>
+        </p:nvSpPr>
+        <p:spPr>
+          <a:xfrm>
+            <a:off x="11535811" y="6446520"/>
+            <a:ext cx="168509" cy="228511"/>
+          </a:xfrm>
+          <a:prstGeom prst="rect">
+            <a:avLst/>
+          </a:prstGeom>
+          <a:extLst>
+            <a:ext uri="{C572A759-6A51-4108-AA02-DFA0A04FC94B}">
+              <ma14:wrappingTextBoxFlag xmlns:ma14="http://schemas.microsoft.com/office/mac/drawingml/2011/main" val="1"/>
+            </a:ext>
+          </a:extLst>
+        </p:spPr>
+        <p:txBody>
+          <a:bodyPr/>
+          <a:lstStyle/>
+          <a:p>
+            <a:pPr/>
+            <a:fld id="{86CB4B4D-7CA3-9044-876B-883B54F8677D}" type="slidenum"/>
+          </a:p>
+        </p:txBody>
+      </p:sp>
+      <p:pic>
+        <p:nvPicPr>
+          <p:cNvPr id="135" name="Picture 134" descr="shot_list.png"/>
+          <p:cNvPicPr>
+            <a:picLocks noChangeAspect="1"/>
+          </p:cNvPicPr>
+          <p:nvPr/>
+        </p:nvPicPr>
+        <p:blipFill>
+          <a:blip r:embed="rId2"/>
+          <a:stretch>
+            <a:fillRect/>
+          </a:stretch>
+        </p:blipFill>
+        <p:spPr>
+          <a:xfrm>
+            <a:off x="548640" y="1188720"/>
+            <a:ext cx="5852160" cy="4558525"/>
+          </a:xfrm>
+          <a:prstGeom prst="rect">
+            <a:avLst/>
+          </a:prstGeom>
+        </p:spPr>
+      </p:pic>
+      <p:pic>
+        <p:nvPicPr>
+          <p:cNvPr id="136" name="Picture 135" descr="shot_t1.png"/>
+          <p:cNvPicPr>
+            <a:picLocks noChangeAspect="1"/>
+          </p:cNvPicPr>
+          <p:nvPr/>
+        </p:nvPicPr>
+        <p:blipFill>
+          <a:blip r:embed="rId3"/>
+          <a:stretch>
+            <a:fillRect/>
+          </a:stretch>
+        </p:blipFill>
+        <p:spPr>
+          <a:xfrm>
+            <a:off x="6583680" y="1188720"/>
+            <a:ext cx="5074920" cy="1545544"/>
+          </a:xfrm>
+          <a:prstGeom prst="rect">
+            <a:avLst/>
+          </a:prstGeom>
+        </p:spPr>
+      </p:pic>
+      <p:pic>
+        <p:nvPicPr>
+          <p:cNvPr id="137" name="Picture 136" descr="shot_t2.png"/>
+          <p:cNvPicPr>
+            <a:picLocks noChangeAspect="1"/>
+          </p:cNvPicPr>
+          <p:nvPr/>
+        </p:nvPicPr>
+        <p:blipFill>
+          <a:blip r:embed="rId4"/>
+          <a:stretch>
+            <a:fillRect/>
+          </a:stretch>
+        </p:blipFill>
+        <p:spPr>
+          <a:xfrm>
+            <a:off x="6583680" y="2880360"/>
+            <a:ext cx="5074920" cy="1478346"/>
+          </a:xfrm>
+          <a:prstGeom prst="rect">
+            <a:avLst/>
+          </a:prstGeom>
+        </p:spPr>
+      </p:pic>
+      <p:sp>
+        <p:nvSpPr>
+          <p:cNvPr id="138" name="TextBox 137"/>
+          <p:cNvSpPr txBox="1"/>
+          <p:nvPr/>
+        </p:nvSpPr>
+        <p:spPr>
+          <a:xfrm>
+            <a:off x="6583680" y="4617720"/>
+            <a:ext cx="5074920" cy="1097280"/>
+          </a:xfrm>
+          <a:prstGeom prst="rect">
+            <a:avLst/>
+          </a:prstGeom>
+          <a:noFill/>
+        </p:spPr>
+        <p:txBody>
+          <a:bodyPr wrap="square">
+            <a:spAutoFit/>
+          </a:bodyPr>
+          <a:lstStyle/>
+          <a:p>
+            <a:r>
+              <a:rPr sz="1200" i="1">
+                <a:solidFill>
+                  <a:srgbClr val="687063"/>
+                </a:solidFill>
+              </a:rPr>
+              <a:t>Hadi's 24 photos of 19 Oct in the app: 20 green; the 4 orange ones are the photos with touching seeds, and the sentence tells the user to spread them.</a:t>
             </a:r>
           </a:p>
         </p:txBody>

</xml_diff>